<commit_message>
docs(presentation): fix lifecycle loop arrow; define variables on every formula
Lifecycle: route the "repeats every month" return arrow cleanly below the four
boxes instead of arcing over them. Formula cards: centre the formula in the
panel and add a hairline-separated legend defining each symbol (P, t-21, t-252,
z, x, mu, sigma, E/P, B/P, ROE, margin, Q/V/M/L, w, score) across the four
factor slides, the z-score, composite, and optimiser cards, with an expanded
symbol legend in the appendix.

Co-Authored-By: Claude Opus 4.8 <noreply@anthropic.com>
</commit_message>
<xml_diff>
--- a/presentation/Systematic-Factor-Income-Fund.pptx
+++ b/presentation/Systematic-Factor-Income-Fund.pptx
@@ -6103,8 +6103,8 @@
         </p:nvSpPr>
         <p:spPr>
           <a:xfrm>
-            <a:off x="640080" y="4224528"/>
-            <a:ext cx="5486400" cy="1234440"/>
+            <a:off x="640080" y="4087368"/>
+            <a:ext cx="5486400" cy="1600200"/>
           </a:xfrm>
           <a:prstGeom prst="roundRect">
             <a:avLst>
@@ -6151,7 +6151,7 @@
         </p:nvSpPr>
         <p:spPr>
           <a:xfrm>
-            <a:off x="914400" y="4370832"/>
+            <a:off x="914400" y="4233672"/>
             <a:ext cx="4937760" cy="274320"/>
           </a:xfrm>
           <a:prstGeom prst="rect">
@@ -6198,8 +6198,8 @@
         </p:blipFill>
         <p:spPr>
           <a:xfrm>
-            <a:off x="2568497" y="4681728"/>
-            <a:ext cx="1629565" cy="777240"/>
+            <a:off x="2683525" y="4507992"/>
+            <a:ext cx="1399509" cy="667512"/>
           </a:xfrm>
           <a:prstGeom prst="rect">
             <a:avLst/>
@@ -6208,33 +6208,77 @@
       </p:pic>
       <p:sp>
         <p:nvSpPr>
-          <p:cNvPr id="12" name="TextBox 11"/>
-          <p:cNvSpPr txBox="1"/>
-          <p:nvPr/>
-        </p:nvSpPr>
-        <p:spPr>
-          <a:xfrm>
-            <a:off x="868680" y="5641848"/>
-            <a:ext cx="5303520" cy="457200"/>
-          </a:xfrm>
-          <a:prstGeom prst="rect">
-            <a:avLst/>
-          </a:prstGeom>
-          <a:noFill/>
-        </p:spPr>
-        <p:txBody>
-          <a:bodyPr wrap="square" anchor="t" lIns="0" rIns="0" tIns="0" bIns="0">
-            <a:spAutoFit/>
-          </a:bodyPr>
-          <a:lstStyle/>
-          <a:p>
-            <a:pPr algn="l">
+          <p:cNvPr id="12" name="Rectangle 11"/>
+          <p:cNvSpPr/>
+          <p:nvPr/>
+        </p:nvSpPr>
+        <p:spPr>
+          <a:xfrm>
+            <a:off x="1143000" y="5193792"/>
+            <a:ext cx="4480560" cy="12700"/>
+          </a:xfrm>
+          <a:prstGeom prst="rect">
+            <a:avLst/>
+          </a:prstGeom>
+          <a:solidFill>
+            <a:srgbClr val="DDE4EA"/>
+          </a:solidFill>
+          <a:ln>
+            <a:noFill/>
+          </a:ln>
+          <a:effectLst/>
+        </p:spPr>
+        <p:style>
+          <a:lnRef idx="1">
+            <a:schemeClr val="accent1"/>
+          </a:lnRef>
+          <a:fillRef idx="3">
+            <a:schemeClr val="accent1"/>
+          </a:fillRef>
+          <a:effectRef idx="2">
+            <a:schemeClr val="accent1"/>
+          </a:effectRef>
+          <a:fontRef idx="minor">
+            <a:schemeClr val="lt1"/>
+          </a:fontRef>
+        </p:style>
+        <p:txBody>
+          <a:bodyPr rtlCol="0" anchor="ctr"/>
+          <a:lstStyle/>
+          <a:p>
+            <a:pPr algn="ctr"/>
+          </a:p>
+        </p:txBody>
+      </p:sp>
+      <p:sp>
+        <p:nvSpPr>
+          <p:cNvPr id="13" name="TextBox 12"/>
+          <p:cNvSpPr txBox="1"/>
+          <p:nvPr/>
+        </p:nvSpPr>
+        <p:spPr>
+          <a:xfrm>
+            <a:off x="1005840" y="5266944"/>
+            <a:ext cx="4754880" cy="384048"/>
+          </a:xfrm>
+          <a:prstGeom prst="rect">
+            <a:avLst/>
+          </a:prstGeom>
+          <a:noFill/>
+        </p:spPr>
+        <p:txBody>
+          <a:bodyPr wrap="square" anchor="ctr" lIns="0" rIns="0" tIns="0" bIns="0">
+            <a:spAutoFit/>
+          </a:bodyPr>
+          <a:lstStyle/>
+          <a:p>
+            <a:pPr algn="ctr">
               <a:lnSpc>
                 <a:spcPct val="110000"/>
               </a:lnSpc>
             </a:pPr>
             <a:r>
-              <a:rPr sz="1250" b="1">
+              <a:rPr sz="1150" b="1">
                 <a:solidFill>
                   <a:srgbClr val="0E1B2A"/>
                 </a:solidFill>
@@ -6243,16 +6287,16 @@
               <a:t>x</a:t>
             </a:r>
             <a:r>
-              <a:rPr sz="1250" b="0">
+              <a:rPr sz="1150" b="0">
                 <a:solidFill>
                   <a:srgbClr val="6B7787"/>
                 </a:solidFill>
                 <a:latin typeface="Avenir Next"/>
               </a:rPr>
-              <a:t> the company's value    </a:t>
-            </a:r>
-            <a:r>
-              <a:rPr sz="1250" b="1">
+              <a:t>  company value     </a:t>
+            </a:r>
+            <a:r>
+              <a:rPr sz="1150" b="1">
                 <a:solidFill>
                   <a:srgbClr val="0E1B2A"/>
                 </a:solidFill>
@@ -6261,16 +6305,16 @@
               <a:t>μ</a:t>
             </a:r>
             <a:r>
-              <a:rPr sz="1250" b="0">
+              <a:rPr sz="1150" b="0">
                 <a:solidFill>
                   <a:srgbClr val="6B7787"/>
                 </a:solidFill>
                 <a:latin typeface="Avenir Next"/>
               </a:rPr>
-              <a:t> the average    </a:t>
-            </a:r>
-            <a:r>
-              <a:rPr sz="1250" b="1">
+              <a:t>  the average     </a:t>
+            </a:r>
+            <a:r>
+              <a:rPr sz="1150" b="1">
                 <a:solidFill>
                   <a:srgbClr val="0E1B2A"/>
                 </a:solidFill>
@@ -6279,20 +6323,20 @@
               <a:t>σ</a:t>
             </a:r>
             <a:r>
-              <a:rPr sz="1250" b="0">
+              <a:rPr sz="1150" b="0">
                 <a:solidFill>
                   <a:srgbClr val="6B7787"/>
                 </a:solidFill>
                 <a:latin typeface="Avenir Next"/>
               </a:rPr>
-              <a:t> standard deviation</a:t>
+              <a:t>  standard deviation</a:t>
             </a:r>
           </a:p>
         </p:txBody>
       </p:sp>
       <p:pic>
         <p:nvPicPr>
-          <p:cNvPr id="13" name="Picture 12" descr="bell.png"/>
+          <p:cNvPr id="14" name="Picture 13" descr="bell.png"/>
           <p:cNvPicPr>
             <a:picLocks noChangeAspect="1"/>
           </p:cNvPicPr>
@@ -6316,7 +6360,7 @@
       </p:pic>
       <p:sp>
         <p:nvSpPr>
-          <p:cNvPr id="14" name="TextBox 13"/>
+          <p:cNvPr id="15" name="TextBox 14"/>
           <p:cNvSpPr txBox="1"/>
           <p:nvPr/>
         </p:nvSpPr>
@@ -6355,7 +6399,7 @@
       </p:sp>
       <p:sp>
         <p:nvSpPr>
-          <p:cNvPr id="15" name="TextBox 14"/>
+          <p:cNvPr id="16" name="TextBox 15"/>
           <p:cNvSpPr txBox="1"/>
           <p:nvPr/>
         </p:nvSpPr>
@@ -6801,8 +6845,8 @@
         </p:nvSpPr>
         <p:spPr>
           <a:xfrm>
-            <a:off x="640080" y="4572000"/>
-            <a:ext cx="10908792" cy="1417320"/>
+            <a:off x="640080" y="4389120"/>
+            <a:ext cx="10908792" cy="1600200"/>
           </a:xfrm>
           <a:prstGeom prst="roundRect">
             <a:avLst>
@@ -6849,7 +6893,7 @@
         </p:nvSpPr>
         <p:spPr>
           <a:xfrm>
-            <a:off x="914400" y="4718304"/>
+            <a:off x="914400" y="4535424"/>
             <a:ext cx="10360152" cy="274320"/>
           </a:xfrm>
           <a:prstGeom prst="rect">
@@ -6896,41 +6940,145 @@
         </p:blipFill>
         <p:spPr>
           <a:xfrm>
-            <a:off x="4292281" y="5029200"/>
-            <a:ext cx="3604390" cy="457199"/>
+            <a:off x="3463265" y="4809744"/>
+            <a:ext cx="5262421" cy="667512"/>
           </a:xfrm>
           <a:prstGeom prst="rect">
             <a:avLst/>
           </a:prstGeom>
         </p:spPr>
       </p:pic>
-      <p:pic>
-        <p:nvPicPr>
-          <p:cNvPr id="12" name="Picture 11" descr="f_value_w.png"/>
-          <p:cNvPicPr>
-            <a:picLocks noChangeAspect="1"/>
-          </p:cNvPicPr>
-          <p:nvPr/>
-        </p:nvPicPr>
-        <p:blipFill>
-          <a:blip r:embed="rId3"/>
-          <a:stretch>
-            <a:fillRect/>
-          </a:stretch>
-        </p:blipFill>
-        <p:spPr>
-          <a:xfrm>
-            <a:off x="5033312" y="5422392"/>
-            <a:ext cx="2122327" cy="457200"/>
-          </a:xfrm>
-          <a:prstGeom prst="rect">
-            <a:avLst/>
-          </a:prstGeom>
-        </p:spPr>
-      </p:pic>
+      <p:sp>
+        <p:nvSpPr>
+          <p:cNvPr id="12" name="Rectangle 11"/>
+          <p:cNvSpPr/>
+          <p:nvPr/>
+        </p:nvSpPr>
+        <p:spPr>
+          <a:xfrm>
+            <a:off x="1143000" y="5495544"/>
+            <a:ext cx="9902952" cy="12700"/>
+          </a:xfrm>
+          <a:prstGeom prst="rect">
+            <a:avLst/>
+          </a:prstGeom>
+          <a:solidFill>
+            <a:srgbClr val="DDE4EA"/>
+          </a:solidFill>
+          <a:ln>
+            <a:noFill/>
+          </a:ln>
+          <a:effectLst/>
+        </p:spPr>
+        <p:style>
+          <a:lnRef idx="1">
+            <a:schemeClr val="accent1"/>
+          </a:lnRef>
+          <a:fillRef idx="3">
+            <a:schemeClr val="accent1"/>
+          </a:fillRef>
+          <a:effectRef idx="2">
+            <a:schemeClr val="accent1"/>
+          </a:effectRef>
+          <a:fontRef idx="minor">
+            <a:schemeClr val="lt1"/>
+          </a:fontRef>
+        </p:style>
+        <p:txBody>
+          <a:bodyPr rtlCol="0" anchor="ctr"/>
+          <a:lstStyle/>
+          <a:p>
+            <a:pPr algn="ctr"/>
+          </a:p>
+        </p:txBody>
+      </p:sp>
       <p:sp>
         <p:nvSpPr>
           <p:cNvPr id="13" name="TextBox 12"/>
+          <p:cNvSpPr txBox="1"/>
+          <p:nvPr/>
+        </p:nvSpPr>
+        <p:spPr>
+          <a:xfrm>
+            <a:off x="1005840" y="5568696"/>
+            <a:ext cx="10177272" cy="384048"/>
+          </a:xfrm>
+          <a:prstGeom prst="rect">
+            <a:avLst/>
+          </a:prstGeom>
+          <a:noFill/>
+        </p:spPr>
+        <p:txBody>
+          <a:bodyPr wrap="square" anchor="ctr" lIns="0" rIns="0" tIns="0" bIns="0">
+            <a:spAutoFit/>
+          </a:bodyPr>
+          <a:lstStyle/>
+          <a:p>
+            <a:pPr algn="ctr">
+              <a:lnSpc>
+                <a:spcPct val="110000"/>
+              </a:lnSpc>
+            </a:pPr>
+            <a:r>
+              <a:rPr sz="1150" b="1">
+                <a:solidFill>
+                  <a:srgbClr val="0E1B2A"/>
+                </a:solidFill>
+                <a:latin typeface="Avenir Next"/>
+              </a:rPr>
+              <a:t>E/P</a:t>
+            </a:r>
+            <a:r>
+              <a:rPr sz="1150" b="0">
+                <a:solidFill>
+                  <a:srgbClr val="6B7787"/>
+                </a:solidFill>
+                <a:latin typeface="Avenir Next"/>
+              </a:rPr>
+              <a:t>  earnings yield = 1 ÷ (P/E)         </a:t>
+            </a:r>
+            <a:r>
+              <a:rPr sz="1150" b="1">
+                <a:solidFill>
+                  <a:srgbClr val="0E1B2A"/>
+                </a:solidFill>
+                <a:latin typeface="Avenir Next"/>
+              </a:rPr>
+              <a:t>B/P</a:t>
+            </a:r>
+            <a:r>
+              <a:rPr sz="1150" b="0">
+                <a:solidFill>
+                  <a:srgbClr val="6B7787"/>
+                </a:solidFill>
+                <a:latin typeface="Avenir Next"/>
+              </a:rPr>
+              <a:t>  book yield = 1 ÷ (P/B)         </a:t>
+            </a:r>
+            <a:r>
+              <a:rPr sz="1150" b="1">
+                <a:solidFill>
+                  <a:srgbClr val="0E1B2A"/>
+                </a:solidFill>
+                <a:latin typeface="Avenir Next"/>
+              </a:rPr>
+              <a:t>z</a:t>
+            </a:r>
+            <a:r>
+              <a:rPr sz="1150" b="0">
+                <a:solidFill>
+                  <a:srgbClr val="6B7787"/>
+                </a:solidFill>
+                <a:latin typeface="Avenir Next"/>
+              </a:rPr>
+              <a:t>  standardised score</a:t>
+            </a:r>
+          </a:p>
+        </p:txBody>
+      </p:sp>
+      <p:sp>
+        <p:nvSpPr>
+          <p:cNvPr id="14" name="TextBox 13"/>
           <p:cNvSpPr txBox="1"/>
           <p:nvPr/>
         </p:nvSpPr>
@@ -6978,7 +7126,7 @@
       </p:sp>
       <p:sp>
         <p:nvSpPr>
-          <p:cNvPr id="14" name="TextBox 13"/>
+          <p:cNvPr id="15" name="TextBox 14"/>
           <p:cNvSpPr txBox="1"/>
           <p:nvPr/>
         </p:nvSpPr>
@@ -7017,7 +7165,7 @@
       </p:sp>
       <p:sp>
         <p:nvSpPr>
-          <p:cNvPr id="15" name="TextBox 14"/>
+          <p:cNvPr id="16" name="TextBox 15"/>
           <p:cNvSpPr txBox="1"/>
           <p:nvPr/>
         </p:nvSpPr>
@@ -7463,8 +7611,8 @@
         </p:nvSpPr>
         <p:spPr>
           <a:xfrm>
-            <a:off x="640080" y="4709160"/>
-            <a:ext cx="10908792" cy="1280160"/>
+            <a:off x="640080" y="4389120"/>
+            <a:ext cx="10908792" cy="1600200"/>
           </a:xfrm>
           <a:prstGeom prst="roundRect">
             <a:avLst>
@@ -7511,7 +7659,7 @@
         </p:nvSpPr>
         <p:spPr>
           <a:xfrm>
-            <a:off x="914400" y="4855464"/>
+            <a:off x="914400" y="4535424"/>
             <a:ext cx="10360152" cy="274320"/>
           </a:xfrm>
           <a:prstGeom prst="rect">
@@ -7558,8 +7706,8 @@
         </p:blipFill>
         <p:spPr>
           <a:xfrm>
-            <a:off x="3966029" y="5166360"/>
-            <a:ext cx="4256893" cy="822960"/>
+            <a:off x="4368069" y="4809744"/>
+            <a:ext cx="3452813" cy="667512"/>
           </a:xfrm>
           <a:prstGeom prst="rect">
             <a:avLst/>
@@ -7568,7 +7716,153 @@
       </p:pic>
       <p:sp>
         <p:nvSpPr>
-          <p:cNvPr id="12" name="TextBox 11"/>
+          <p:cNvPr id="12" name="Rectangle 11"/>
+          <p:cNvSpPr/>
+          <p:nvPr/>
+        </p:nvSpPr>
+        <p:spPr>
+          <a:xfrm>
+            <a:off x="1143000" y="5495544"/>
+            <a:ext cx="9902952" cy="12700"/>
+          </a:xfrm>
+          <a:prstGeom prst="rect">
+            <a:avLst/>
+          </a:prstGeom>
+          <a:solidFill>
+            <a:srgbClr val="DDE4EA"/>
+          </a:solidFill>
+          <a:ln>
+            <a:noFill/>
+          </a:ln>
+          <a:effectLst/>
+        </p:spPr>
+        <p:style>
+          <a:lnRef idx="1">
+            <a:schemeClr val="accent1"/>
+          </a:lnRef>
+          <a:fillRef idx="3">
+            <a:schemeClr val="accent1"/>
+          </a:fillRef>
+          <a:effectRef idx="2">
+            <a:schemeClr val="accent1"/>
+          </a:effectRef>
+          <a:fontRef idx="minor">
+            <a:schemeClr val="lt1"/>
+          </a:fontRef>
+        </p:style>
+        <p:txBody>
+          <a:bodyPr rtlCol="0" anchor="ctr"/>
+          <a:lstStyle/>
+          <a:p>
+            <a:pPr algn="ctr"/>
+          </a:p>
+        </p:txBody>
+      </p:sp>
+      <p:sp>
+        <p:nvSpPr>
+          <p:cNvPr id="13" name="TextBox 12"/>
+          <p:cNvSpPr txBox="1"/>
+          <p:nvPr/>
+        </p:nvSpPr>
+        <p:spPr>
+          <a:xfrm>
+            <a:off x="1005840" y="5568696"/>
+            <a:ext cx="10177272" cy="384048"/>
+          </a:xfrm>
+          <a:prstGeom prst="rect">
+            <a:avLst/>
+          </a:prstGeom>
+          <a:noFill/>
+        </p:spPr>
+        <p:txBody>
+          <a:bodyPr wrap="square" anchor="ctr" lIns="0" rIns="0" tIns="0" bIns="0">
+            <a:spAutoFit/>
+          </a:bodyPr>
+          <a:lstStyle/>
+          <a:p>
+            <a:pPr algn="ctr">
+              <a:lnSpc>
+                <a:spcPct val="110000"/>
+              </a:lnSpc>
+            </a:pPr>
+            <a:r>
+              <a:rPr sz="1150" b="1">
+                <a:solidFill>
+                  <a:srgbClr val="0E1B2A"/>
+                </a:solidFill>
+                <a:latin typeface="Avenir Next"/>
+              </a:rPr>
+              <a:t>P</a:t>
+            </a:r>
+            <a:r>
+              <a:rPr sz="1150" b="0">
+                <a:solidFill>
+                  <a:srgbClr val="6B7787"/>
+                </a:solidFill>
+                <a:latin typeface="Avenir Next"/>
+              </a:rPr>
+              <a:t>  share price        </a:t>
+            </a:r>
+            <a:r>
+              <a:rPr sz="1150" b="1">
+                <a:solidFill>
+                  <a:srgbClr val="0E1B2A"/>
+                </a:solidFill>
+                <a:latin typeface="Avenir Next"/>
+              </a:rPr>
+              <a:t>t−21</a:t>
+            </a:r>
+            <a:r>
+              <a:rPr sz="1150" b="0">
+                <a:solidFill>
+                  <a:srgbClr val="6B7787"/>
+                </a:solidFill>
+                <a:latin typeface="Avenir Next"/>
+              </a:rPr>
+              <a:t>  ≈ 1 month ago        </a:t>
+            </a:r>
+            <a:r>
+              <a:rPr sz="1150" b="1">
+                <a:solidFill>
+                  <a:srgbClr val="0E1B2A"/>
+                </a:solidFill>
+                <a:latin typeface="Avenir Next"/>
+              </a:rPr>
+              <a:t>t−252</a:t>
+            </a:r>
+            <a:r>
+              <a:rPr sz="1150" b="0">
+                <a:solidFill>
+                  <a:srgbClr val="6B7787"/>
+                </a:solidFill>
+                <a:latin typeface="Avenir Next"/>
+              </a:rPr>
+              <a:t>  ≈ 1 year ago        </a:t>
+            </a:r>
+            <a:r>
+              <a:rPr sz="1150" b="1">
+                <a:solidFill>
+                  <a:srgbClr val="0E1B2A"/>
+                </a:solidFill>
+                <a:latin typeface="Avenir Next"/>
+              </a:rPr>
+              <a:t>z</a:t>
+            </a:r>
+            <a:r>
+              <a:rPr sz="1150" b="0">
+                <a:solidFill>
+                  <a:srgbClr val="6B7787"/>
+                </a:solidFill>
+                <a:latin typeface="Avenir Next"/>
+              </a:rPr>
+              <a:t>  standardised score</a:t>
+            </a:r>
+          </a:p>
+        </p:txBody>
+      </p:sp>
+      <p:sp>
+        <p:nvSpPr>
+          <p:cNvPr id="14" name="TextBox 13"/>
           <p:cNvSpPr txBox="1"/>
           <p:nvPr/>
         </p:nvSpPr>
@@ -7616,7 +7910,7 @@
       </p:sp>
       <p:sp>
         <p:nvSpPr>
-          <p:cNvPr id="13" name="TextBox 12"/>
+          <p:cNvPr id="15" name="TextBox 14"/>
           <p:cNvSpPr txBox="1"/>
           <p:nvPr/>
         </p:nvSpPr>
@@ -7655,7 +7949,7 @@
       </p:sp>
       <p:sp>
         <p:nvSpPr>
-          <p:cNvPr id="14" name="TextBox 13"/>
+          <p:cNvPr id="16" name="TextBox 15"/>
           <p:cNvSpPr txBox="1"/>
           <p:nvPr/>
         </p:nvSpPr>
@@ -8101,8 +8395,8 @@
         </p:nvSpPr>
         <p:spPr>
           <a:xfrm>
-            <a:off x="640080" y="4709160"/>
-            <a:ext cx="10908792" cy="1280160"/>
+            <a:off x="640080" y="4389120"/>
+            <a:ext cx="10908792" cy="1600200"/>
           </a:xfrm>
           <a:prstGeom prst="roundRect">
             <a:avLst>
@@ -8149,7 +8443,7 @@
         </p:nvSpPr>
         <p:spPr>
           <a:xfrm>
-            <a:off x="914400" y="4855464"/>
+            <a:off x="914400" y="4535424"/>
             <a:ext cx="10360152" cy="274320"/>
           </a:xfrm>
           <a:prstGeom prst="rect">
@@ -8196,8 +8490,8 @@
         </p:blipFill>
         <p:spPr>
           <a:xfrm>
-            <a:off x="2290905" y="5166360"/>
-            <a:ext cx="7607142" cy="822960"/>
+            <a:off x="3009357" y="4809744"/>
+            <a:ext cx="6170238" cy="667512"/>
           </a:xfrm>
           <a:prstGeom prst="rect">
             <a:avLst/>
@@ -8206,7 +8500,135 @@
       </p:pic>
       <p:sp>
         <p:nvSpPr>
-          <p:cNvPr id="12" name="TextBox 11"/>
+          <p:cNvPr id="12" name="Rectangle 11"/>
+          <p:cNvSpPr/>
+          <p:nvPr/>
+        </p:nvSpPr>
+        <p:spPr>
+          <a:xfrm>
+            <a:off x="1143000" y="5495544"/>
+            <a:ext cx="9902952" cy="12700"/>
+          </a:xfrm>
+          <a:prstGeom prst="rect">
+            <a:avLst/>
+          </a:prstGeom>
+          <a:solidFill>
+            <a:srgbClr val="DDE4EA"/>
+          </a:solidFill>
+          <a:ln>
+            <a:noFill/>
+          </a:ln>
+          <a:effectLst/>
+        </p:spPr>
+        <p:style>
+          <a:lnRef idx="1">
+            <a:schemeClr val="accent1"/>
+          </a:lnRef>
+          <a:fillRef idx="3">
+            <a:schemeClr val="accent1"/>
+          </a:fillRef>
+          <a:effectRef idx="2">
+            <a:schemeClr val="accent1"/>
+          </a:effectRef>
+          <a:fontRef idx="minor">
+            <a:schemeClr val="lt1"/>
+          </a:fontRef>
+        </p:style>
+        <p:txBody>
+          <a:bodyPr rtlCol="0" anchor="ctr"/>
+          <a:lstStyle/>
+          <a:p>
+            <a:pPr algn="ctr"/>
+          </a:p>
+        </p:txBody>
+      </p:sp>
+      <p:sp>
+        <p:nvSpPr>
+          <p:cNvPr id="13" name="TextBox 12"/>
+          <p:cNvSpPr txBox="1"/>
+          <p:nvPr/>
+        </p:nvSpPr>
+        <p:spPr>
+          <a:xfrm>
+            <a:off x="1005840" y="5568696"/>
+            <a:ext cx="10177272" cy="384048"/>
+          </a:xfrm>
+          <a:prstGeom prst="rect">
+            <a:avLst/>
+          </a:prstGeom>
+          <a:noFill/>
+        </p:spPr>
+        <p:txBody>
+          <a:bodyPr wrap="square" anchor="ctr" lIns="0" rIns="0" tIns="0" bIns="0">
+            <a:spAutoFit/>
+          </a:bodyPr>
+          <a:lstStyle/>
+          <a:p>
+            <a:pPr algn="ctr">
+              <a:lnSpc>
+                <a:spcPct val="110000"/>
+              </a:lnSpc>
+            </a:pPr>
+            <a:r>
+              <a:rPr sz="1150" b="1">
+                <a:solidFill>
+                  <a:srgbClr val="0E1B2A"/>
+                </a:solidFill>
+                <a:latin typeface="Avenir Next"/>
+              </a:rPr>
+              <a:t>ROE</a:t>
+            </a:r>
+            <a:r>
+              <a:rPr sz="1150" b="0">
+                <a:solidFill>
+                  <a:srgbClr val="6B7787"/>
+                </a:solidFill>
+                <a:latin typeface="Avenir Next"/>
+              </a:rPr>
+              <a:t>  return on equity         </a:t>
+            </a:r>
+            <a:r>
+              <a:rPr sz="1150" b="1">
+                <a:solidFill>
+                  <a:srgbClr val="0E1B2A"/>
+                </a:solidFill>
+                <a:latin typeface="Avenir Next"/>
+              </a:rPr>
+              <a:t>margin</a:t>
+            </a:r>
+            <a:r>
+              <a:rPr sz="1150" b="0">
+                <a:solidFill>
+                  <a:srgbClr val="6B7787"/>
+                </a:solidFill>
+                <a:latin typeface="Avenir Next"/>
+              </a:rPr>
+              <a:t>  gross margin         </a:t>
+            </a:r>
+            <a:r>
+              <a:rPr sz="1150" b="1">
+                <a:solidFill>
+                  <a:srgbClr val="0E1B2A"/>
+                </a:solidFill>
+                <a:latin typeface="Avenir Next"/>
+              </a:rPr>
+              <a:t>z</a:t>
+            </a:r>
+            <a:r>
+              <a:rPr sz="1150" b="0">
+                <a:solidFill>
+                  <a:srgbClr val="6B7787"/>
+                </a:solidFill>
+                <a:latin typeface="Avenir Next"/>
+              </a:rPr>
+              <a:t>  standardised score</a:t>
+            </a:r>
+          </a:p>
+        </p:txBody>
+      </p:sp>
+      <p:sp>
+        <p:nvSpPr>
+          <p:cNvPr id="14" name="TextBox 13"/>
           <p:cNvSpPr txBox="1"/>
           <p:nvPr/>
         </p:nvSpPr>
@@ -8254,7 +8676,7 @@
       </p:sp>
       <p:sp>
         <p:nvSpPr>
-          <p:cNvPr id="13" name="TextBox 12"/>
+          <p:cNvPr id="15" name="TextBox 14"/>
           <p:cNvSpPr txBox="1"/>
           <p:nvPr/>
         </p:nvSpPr>
@@ -8293,7 +8715,7 @@
       </p:sp>
       <p:sp>
         <p:nvSpPr>
-          <p:cNvPr id="14" name="TextBox 13"/>
+          <p:cNvPr id="16" name="TextBox 15"/>
           <p:cNvSpPr txBox="1"/>
           <p:nvPr/>
         </p:nvSpPr>
@@ -8739,8 +9161,8 @@
         </p:nvSpPr>
         <p:spPr>
           <a:xfrm>
-            <a:off x="640080" y="4709160"/>
-            <a:ext cx="10908792" cy="1280160"/>
+            <a:off x="640080" y="4389120"/>
+            <a:ext cx="10908792" cy="1600200"/>
           </a:xfrm>
           <a:prstGeom prst="roundRect">
             <a:avLst>
@@ -8787,7 +9209,7 @@
         </p:nvSpPr>
         <p:spPr>
           <a:xfrm>
-            <a:off x="914400" y="4855464"/>
+            <a:off x="914400" y="4535424"/>
             <a:ext cx="10360152" cy="274320"/>
           </a:xfrm>
           <a:prstGeom prst="rect">
@@ -8834,8 +9256,8 @@
         </p:blipFill>
         <p:spPr>
           <a:xfrm>
-            <a:off x="3624100" y="5166360"/>
-            <a:ext cx="4940752" cy="822960"/>
+            <a:off x="4090726" y="4809744"/>
+            <a:ext cx="4007499" cy="667512"/>
           </a:xfrm>
           <a:prstGeom prst="rect">
             <a:avLst/>
@@ -8844,7 +9266,117 @@
       </p:pic>
       <p:sp>
         <p:nvSpPr>
-          <p:cNvPr id="12" name="TextBox 11"/>
+          <p:cNvPr id="12" name="Rectangle 11"/>
+          <p:cNvSpPr/>
+          <p:nvPr/>
+        </p:nvSpPr>
+        <p:spPr>
+          <a:xfrm>
+            <a:off x="1143000" y="5495544"/>
+            <a:ext cx="9902952" cy="12700"/>
+          </a:xfrm>
+          <a:prstGeom prst="rect">
+            <a:avLst/>
+          </a:prstGeom>
+          <a:solidFill>
+            <a:srgbClr val="DDE4EA"/>
+          </a:solidFill>
+          <a:ln>
+            <a:noFill/>
+          </a:ln>
+          <a:effectLst/>
+        </p:spPr>
+        <p:style>
+          <a:lnRef idx="1">
+            <a:schemeClr val="accent1"/>
+          </a:lnRef>
+          <a:fillRef idx="3">
+            <a:schemeClr val="accent1"/>
+          </a:fillRef>
+          <a:effectRef idx="2">
+            <a:schemeClr val="accent1"/>
+          </a:effectRef>
+          <a:fontRef idx="minor">
+            <a:schemeClr val="lt1"/>
+          </a:fontRef>
+        </p:style>
+        <p:txBody>
+          <a:bodyPr rtlCol="0" anchor="ctr"/>
+          <a:lstStyle/>
+          <a:p>
+            <a:pPr algn="ctr"/>
+          </a:p>
+        </p:txBody>
+      </p:sp>
+      <p:sp>
+        <p:nvSpPr>
+          <p:cNvPr id="13" name="TextBox 12"/>
+          <p:cNvSpPr txBox="1"/>
+          <p:nvPr/>
+        </p:nvSpPr>
+        <p:spPr>
+          <a:xfrm>
+            <a:off x="1005840" y="5568696"/>
+            <a:ext cx="10177272" cy="384048"/>
+          </a:xfrm>
+          <a:prstGeom prst="rect">
+            <a:avLst/>
+          </a:prstGeom>
+          <a:noFill/>
+        </p:spPr>
+        <p:txBody>
+          <a:bodyPr wrap="square" anchor="ctr" lIns="0" rIns="0" tIns="0" bIns="0">
+            <a:spAutoFit/>
+          </a:bodyPr>
+          <a:lstStyle/>
+          <a:p>
+            <a:pPr algn="ctr">
+              <a:lnSpc>
+                <a:spcPct val="110000"/>
+              </a:lnSpc>
+            </a:pPr>
+            <a:r>
+              <a:rPr sz="1150" b="1">
+                <a:solidFill>
+                  <a:srgbClr val="0E1B2A"/>
+                </a:solidFill>
+                <a:latin typeface="Avenir Next"/>
+              </a:rPr>
+              <a:t>σ</a:t>
+            </a:r>
+            <a:r>
+              <a:rPr sz="1150" b="0">
+                <a:solidFill>
+                  <a:srgbClr val="6B7787"/>
+                </a:solidFill>
+                <a:latin typeface="Avenir Next"/>
+              </a:rPr>
+              <a:t>  volatility = the size of daily price swings         </a:t>
+            </a:r>
+            <a:r>
+              <a:rPr sz="1150" b="1">
+                <a:solidFill>
+                  <a:srgbClr val="0E1B2A"/>
+                </a:solidFill>
+                <a:latin typeface="Avenir Next"/>
+              </a:rPr>
+              <a:t>z</a:t>
+            </a:r>
+            <a:r>
+              <a:rPr sz="1150" b="0">
+                <a:solidFill>
+                  <a:srgbClr val="6B7787"/>
+                </a:solidFill>
+                <a:latin typeface="Avenir Next"/>
+              </a:rPr>
+              <a:t>  standardised score</a:t>
+            </a:r>
+          </a:p>
+        </p:txBody>
+      </p:sp>
+      <p:sp>
+        <p:nvSpPr>
+          <p:cNvPr id="14" name="TextBox 13"/>
           <p:cNvSpPr txBox="1"/>
           <p:nvPr/>
         </p:nvSpPr>
@@ -8892,7 +9424,7 @@
       </p:sp>
       <p:sp>
         <p:nvSpPr>
-          <p:cNvPr id="13" name="TextBox 12"/>
+          <p:cNvPr id="15" name="TextBox 14"/>
           <p:cNvSpPr txBox="1"/>
           <p:nvPr/>
         </p:nvSpPr>
@@ -8931,7 +9463,7 @@
       </p:sp>
       <p:sp>
         <p:nvSpPr>
-          <p:cNvPr id="14" name="TextBox 13"/>
+          <p:cNvPr id="16" name="TextBox 15"/>
           <p:cNvSpPr txBox="1"/>
           <p:nvPr/>
         </p:nvSpPr>
@@ -9378,7 +9910,7 @@
         <p:spPr>
           <a:xfrm>
             <a:off x="6492240" y="2670048"/>
-            <a:ext cx="5029200" cy="1371600"/>
+            <a:ext cx="5029200" cy="1554480"/>
           </a:xfrm>
           <a:prstGeom prst="roundRect">
             <a:avLst>
@@ -9472,8 +10004,8 @@
         </p:blipFill>
         <p:spPr>
           <a:xfrm>
-            <a:off x="6766559" y="3141002"/>
-            <a:ext cx="4480560" cy="886891"/>
+            <a:off x="7436200" y="3090672"/>
+            <a:ext cx="3141280" cy="621792"/>
           </a:xfrm>
           <a:prstGeom prst="rect">
             <a:avLst/>
@@ -9482,13 +10014,105 @@
       </p:pic>
       <p:sp>
         <p:nvSpPr>
-          <p:cNvPr id="12" name="TextBox 11"/>
-          <p:cNvSpPr txBox="1"/>
-          <p:nvPr/>
-        </p:nvSpPr>
-        <p:spPr>
-          <a:xfrm>
-            <a:off x="6492240" y="4270248"/>
+          <p:cNvPr id="12" name="Rectangle 11"/>
+          <p:cNvSpPr/>
+          <p:nvPr/>
+        </p:nvSpPr>
+        <p:spPr>
+          <a:xfrm>
+            <a:off x="6995159" y="3730752"/>
+            <a:ext cx="4023360" cy="12700"/>
+          </a:xfrm>
+          <a:prstGeom prst="rect">
+            <a:avLst/>
+          </a:prstGeom>
+          <a:solidFill>
+            <a:srgbClr val="DDE4EA"/>
+          </a:solidFill>
+          <a:ln>
+            <a:noFill/>
+          </a:ln>
+          <a:effectLst/>
+        </p:spPr>
+        <p:style>
+          <a:lnRef idx="1">
+            <a:schemeClr val="accent1"/>
+          </a:lnRef>
+          <a:fillRef idx="3">
+            <a:schemeClr val="accent1"/>
+          </a:fillRef>
+          <a:effectRef idx="2">
+            <a:schemeClr val="accent1"/>
+          </a:effectRef>
+          <a:fontRef idx="minor">
+            <a:schemeClr val="lt1"/>
+          </a:fontRef>
+        </p:style>
+        <p:txBody>
+          <a:bodyPr rtlCol="0" anchor="ctr"/>
+          <a:lstStyle/>
+          <a:p>
+            <a:pPr algn="ctr"/>
+          </a:p>
+        </p:txBody>
+      </p:sp>
+      <p:sp>
+        <p:nvSpPr>
+          <p:cNvPr id="13" name="TextBox 12"/>
+          <p:cNvSpPr txBox="1"/>
+          <p:nvPr/>
+        </p:nvSpPr>
+        <p:spPr>
+          <a:xfrm>
+            <a:off x="6858000" y="3803904"/>
+            <a:ext cx="4297680" cy="384048"/>
+          </a:xfrm>
+          <a:prstGeom prst="rect">
+            <a:avLst/>
+          </a:prstGeom>
+          <a:noFill/>
+        </p:spPr>
+        <p:txBody>
+          <a:bodyPr wrap="square" anchor="ctr" lIns="0" rIns="0" tIns="0" bIns="0">
+            <a:spAutoFit/>
+          </a:bodyPr>
+          <a:lstStyle/>
+          <a:p>
+            <a:pPr algn="ctr">
+              <a:lnSpc>
+                <a:spcPct val="110000"/>
+              </a:lnSpc>
+            </a:pPr>
+            <a:r>
+              <a:rPr sz="1150" b="1">
+                <a:solidFill>
+                  <a:srgbClr val="0E1B2A"/>
+                </a:solidFill>
+                <a:latin typeface="Avenir Next"/>
+              </a:rPr>
+              <a:t>Q, V, M, L</a:t>
+            </a:r>
+            <a:r>
+              <a:rPr sz="1150" b="0">
+                <a:solidFill>
+                  <a:srgbClr val="6B7787"/>
+                </a:solidFill>
+                <a:latin typeface="Avenir Next"/>
+              </a:rPr>
+              <a:t>  the four factor scores</a:t>
+            </a:r>
+          </a:p>
+        </p:txBody>
+      </p:sp>
+      <p:sp>
+        <p:nvSpPr>
+          <p:cNvPr id="14" name="TextBox 13"/>
+          <p:cNvSpPr txBox="1"/>
+          <p:nvPr/>
+        </p:nvSpPr>
+        <p:spPr>
+          <a:xfrm>
+            <a:off x="6492240" y="4407408"/>
             <a:ext cx="5029200" cy="548640"/>
           </a:xfrm>
           <a:prstGeom prst="rect">
@@ -9514,14 +10138,14 @@
                 </a:solidFill>
                 <a:latin typeface="Avenir Next"/>
               </a:rPr>
-              <a:t>Q, V, M, L are the four factor scores. The highest combined scores become the portfolio.</a:t>
-            </a:r>
-          </a:p>
-        </p:txBody>
-      </p:sp>
-      <p:sp>
-        <p:nvSpPr>
-          <p:cNvPr id="13" name="TextBox 12"/>
+              <a:t>The highest combined scores become the portfolio.</a:t>
+            </a:r>
+          </a:p>
+        </p:txBody>
+      </p:sp>
+      <p:sp>
+        <p:nvSpPr>
+          <p:cNvPr id="15" name="TextBox 14"/>
           <p:cNvSpPr txBox="1"/>
           <p:nvPr/>
         </p:nvSpPr>
@@ -9560,7 +10184,7 @@
       </p:sp>
       <p:sp>
         <p:nvSpPr>
-          <p:cNvPr id="14" name="TextBox 13"/>
+          <p:cNvPr id="16" name="TextBox 15"/>
           <p:cNvSpPr txBox="1"/>
           <p:nvPr/>
         </p:nvSpPr>
@@ -10626,7 +11250,7 @@
         <p:spPr>
           <a:xfrm>
             <a:off x="6492240" y="2624328"/>
-            <a:ext cx="5029200" cy="1234440"/>
+            <a:ext cx="5029200" cy="1554480"/>
           </a:xfrm>
           <a:prstGeom prst="roundRect">
             <a:avLst>
@@ -10720,8 +11344,8 @@
         </p:blipFill>
         <p:spPr>
           <a:xfrm>
-            <a:off x="7648094" y="3081528"/>
-            <a:ext cx="2717489" cy="777240"/>
+            <a:off x="7919844" y="3044952"/>
+            <a:ext cx="2173991" cy="621792"/>
           </a:xfrm>
           <a:prstGeom prst="rect">
             <a:avLst/>
@@ -10730,13 +11354,123 @@
       </p:pic>
       <p:sp>
         <p:nvSpPr>
-          <p:cNvPr id="12" name="TextBox 11"/>
-          <p:cNvSpPr txBox="1"/>
-          <p:nvPr/>
-        </p:nvSpPr>
-        <p:spPr>
-          <a:xfrm>
-            <a:off x="6492240" y="4087368"/>
+          <p:cNvPr id="12" name="Rectangle 11"/>
+          <p:cNvSpPr/>
+          <p:nvPr/>
+        </p:nvSpPr>
+        <p:spPr>
+          <a:xfrm>
+            <a:off x="6995159" y="3685032"/>
+            <a:ext cx="4023360" cy="12700"/>
+          </a:xfrm>
+          <a:prstGeom prst="rect">
+            <a:avLst/>
+          </a:prstGeom>
+          <a:solidFill>
+            <a:srgbClr val="DDE4EA"/>
+          </a:solidFill>
+          <a:ln>
+            <a:noFill/>
+          </a:ln>
+          <a:effectLst/>
+        </p:spPr>
+        <p:style>
+          <a:lnRef idx="1">
+            <a:schemeClr val="accent1"/>
+          </a:lnRef>
+          <a:fillRef idx="3">
+            <a:schemeClr val="accent1"/>
+          </a:fillRef>
+          <a:effectRef idx="2">
+            <a:schemeClr val="accent1"/>
+          </a:effectRef>
+          <a:fontRef idx="minor">
+            <a:schemeClr val="lt1"/>
+          </a:fontRef>
+        </p:style>
+        <p:txBody>
+          <a:bodyPr rtlCol="0" anchor="ctr"/>
+          <a:lstStyle/>
+          <a:p>
+            <a:pPr algn="ctr"/>
+          </a:p>
+        </p:txBody>
+      </p:sp>
+      <p:sp>
+        <p:nvSpPr>
+          <p:cNvPr id="13" name="TextBox 12"/>
+          <p:cNvSpPr txBox="1"/>
+          <p:nvPr/>
+        </p:nvSpPr>
+        <p:spPr>
+          <a:xfrm>
+            <a:off x="6858000" y="3758184"/>
+            <a:ext cx="4297680" cy="384048"/>
+          </a:xfrm>
+          <a:prstGeom prst="rect">
+            <a:avLst/>
+          </a:prstGeom>
+          <a:noFill/>
+        </p:spPr>
+        <p:txBody>
+          <a:bodyPr wrap="square" anchor="ctr" lIns="0" rIns="0" tIns="0" bIns="0">
+            <a:spAutoFit/>
+          </a:bodyPr>
+          <a:lstStyle/>
+          <a:p>
+            <a:pPr algn="ctr">
+              <a:lnSpc>
+                <a:spcPct val="110000"/>
+              </a:lnSpc>
+            </a:pPr>
+            <a:r>
+              <a:rPr sz="1150" b="1">
+                <a:solidFill>
+                  <a:srgbClr val="0E1B2A"/>
+                </a:solidFill>
+                <a:latin typeface="Avenir Next"/>
+              </a:rPr>
+              <a:t>w</a:t>
+            </a:r>
+            <a:r>
+              <a:rPr sz="1150" b="0">
+                <a:solidFill>
+                  <a:srgbClr val="6B7787"/>
+                </a:solidFill>
+                <a:latin typeface="Avenir Next"/>
+              </a:rPr>
+              <a:t>  each stock's weight       </a:t>
+            </a:r>
+            <a:r>
+              <a:rPr sz="1150" b="1">
+                <a:solidFill>
+                  <a:srgbClr val="0E1B2A"/>
+                </a:solidFill>
+                <a:latin typeface="Avenir Next"/>
+              </a:rPr>
+              <a:t>score</a:t>
+            </a:r>
+            <a:r>
+              <a:rPr sz="1150" b="0">
+                <a:solidFill>
+                  <a:srgbClr val="6B7787"/>
+                </a:solidFill>
+                <a:latin typeface="Avenir Next"/>
+              </a:rPr>
+              <a:t>  its combined factor score</a:t>
+            </a:r>
+          </a:p>
+        </p:txBody>
+      </p:sp>
+      <p:sp>
+        <p:nvSpPr>
+          <p:cNvPr id="14" name="TextBox 13"/>
+          <p:cNvSpPr txBox="1"/>
+          <p:nvPr/>
+        </p:nvSpPr>
+        <p:spPr>
+          <a:xfrm>
+            <a:off x="6492240" y="4361688"/>
             <a:ext cx="5029200" cy="640080"/>
           </a:xfrm>
           <a:prstGeom prst="rect">
@@ -10762,14 +11496,14 @@
                 </a:solidFill>
                 <a:latin typeface="Avenir Next"/>
               </a:rPr>
-              <a:t>w is each stock's weight; score is its combined factor score. Read: choose weights that put the most money in the best-scoring names.</a:t>
-            </a:r>
-          </a:p>
-        </p:txBody>
-      </p:sp>
-      <p:sp>
-        <p:nvSpPr>
-          <p:cNvPr id="13" name="TextBox 12"/>
+              <a:t>In plain terms: put the most money in the best-scoring names, within the limits.</a:t>
+            </a:r>
+          </a:p>
+        </p:txBody>
+      </p:sp>
+      <p:sp>
+        <p:nvSpPr>
+          <p:cNvPr id="15" name="TextBox 14"/>
           <p:cNvSpPr txBox="1"/>
           <p:nvPr/>
         </p:nvSpPr>
@@ -10808,7 +11542,7 @@
       </p:sp>
       <p:sp>
         <p:nvSpPr>
-          <p:cNvPr id="14" name="TextBox 13"/>
+          <p:cNvPr id="16" name="TextBox 15"/>
           <p:cNvSpPr txBox="1"/>
           <p:nvPr/>
         </p:nvSpPr>
@@ -15304,8 +16038,8 @@
         </p:blipFill>
         <p:spPr>
           <a:xfrm>
-            <a:off x="640080" y="2258568"/>
-            <a:ext cx="10908792" cy="2837796"/>
+            <a:off x="821273" y="2258568"/>
+            <a:ext cx="10546405" cy="2926080"/>
           </a:xfrm>
           <a:prstGeom prst="rect">
             <a:avLst/>
@@ -29479,8 +30213,8 @@
         </p:blipFill>
         <p:spPr>
           <a:xfrm>
-            <a:off x="914400" y="2493152"/>
-            <a:ext cx="4663440" cy="591534"/>
+            <a:off x="1005840" y="2459031"/>
+            <a:ext cx="4480560" cy="568336"/>
           </a:xfrm>
           <a:prstGeom prst="rect">
             <a:avLst/>
@@ -29590,8 +30324,8 @@
         </p:blipFill>
         <p:spPr>
           <a:xfrm>
-            <a:off x="6519672" y="2338142"/>
-            <a:ext cx="4663440" cy="901555"/>
+            <a:off x="6611112" y="2310099"/>
+            <a:ext cx="4480560" cy="866200"/>
           </a:xfrm>
           <a:prstGeom prst="rect">
             <a:avLst/>
@@ -29701,8 +30435,8 @@
         </p:blipFill>
         <p:spPr>
           <a:xfrm>
-            <a:off x="914400" y="4319748"/>
-            <a:ext cx="4663440" cy="504502"/>
+            <a:off x="1005840" y="4283920"/>
+            <a:ext cx="4480560" cy="484718"/>
           </a:xfrm>
           <a:prstGeom prst="rect">
             <a:avLst/>
@@ -29812,8 +30546,8 @@
         </p:blipFill>
         <p:spPr>
           <a:xfrm>
-            <a:off x="6519672" y="4183615"/>
-            <a:ext cx="4663440" cy="776769"/>
+            <a:off x="6611112" y="4153126"/>
+            <a:ext cx="4480560" cy="746307"/>
           </a:xfrm>
           <a:prstGeom prst="rect">
             <a:avLst/>
@@ -29828,8 +30562,8 @@
         </p:nvSpPr>
         <p:spPr>
           <a:xfrm>
-            <a:off x="640080" y="5394959"/>
-            <a:ext cx="10908792" cy="457200"/>
+            <a:off x="640080" y="5349240"/>
+            <a:ext cx="10908792" cy="548640"/>
           </a:xfrm>
           <a:prstGeom prst="rect">
             <a:avLst/>
@@ -29848,7 +30582,7 @@
               </a:lnSpc>
             </a:pPr>
             <a:r>
-              <a:rPr sz="1200" b="1">
+              <a:rPr sz="1150" b="1">
                 <a:solidFill>
                   <a:srgbClr val="0E1B2A"/>
                 </a:solidFill>
@@ -29857,13 +30591,85 @@
               <a:t>z(·)</a:t>
             </a:r>
             <a:r>
-              <a:rPr sz="1200" b="0">
+              <a:rPr sz="1150" b="0">
                 <a:solidFill>
                   <a:srgbClr val="6B7787"/>
                 </a:solidFill>
                 <a:latin typeface="Avenir Next"/>
               </a:rPr>
-              <a:t> is the standardising score from slide 8; each factor is combined equally into the final score.</a:t>
+              <a:t>  standardised score        </a:t>
+            </a:r>
+            <a:r>
+              <a:rPr sz="1150" b="1">
+                <a:solidFill>
+                  <a:srgbClr val="0E1B2A"/>
+                </a:solidFill>
+                <a:latin typeface="Avenir Next"/>
+              </a:rPr>
+              <a:t>E/P, B/P</a:t>
+            </a:r>
+            <a:r>
+              <a:rPr sz="1150" b="0">
+                <a:solidFill>
+                  <a:srgbClr val="6B7787"/>
+                </a:solidFill>
+                <a:latin typeface="Avenir Next"/>
+              </a:rPr>
+              <a:t>  earnings &amp; book yield        </a:t>
+            </a:r>
+            <a:r>
+              <a:rPr sz="1150" b="1">
+                <a:solidFill>
+                  <a:srgbClr val="0E1B2A"/>
+                </a:solidFill>
+                <a:latin typeface="Avenir Next"/>
+              </a:rPr>
+              <a:t>ROE</a:t>
+            </a:r>
+            <a:r>
+              <a:rPr sz="1150" b="0">
+                <a:solidFill>
+                  <a:srgbClr val="6B7787"/>
+                </a:solidFill>
+                <a:latin typeface="Avenir Next"/>
+              </a:rPr>
+              <a:t>  return on equity        </a:t>
+            </a:r>
+            <a:r>
+              <a:rPr sz="1150" b="1">
+                <a:solidFill>
+                  <a:srgbClr val="0E1B2A"/>
+                </a:solidFill>
+                <a:latin typeface="Avenir Next"/>
+              </a:rPr>
+              <a:t>margin</a:t>
+            </a:r>
+            <a:r>
+              <a:rPr sz="1150" b="0">
+                <a:solidFill>
+                  <a:srgbClr val="6B7787"/>
+                </a:solidFill>
+                <a:latin typeface="Avenir Next"/>
+              </a:rPr>
+              <a:t>  gross margin        </a:t>
+            </a:r>
+            <a:r>
+              <a:rPr sz="1150" b="1">
+                <a:solidFill>
+                  <a:srgbClr val="0E1B2A"/>
+                </a:solidFill>
+                <a:latin typeface="Avenir Next"/>
+              </a:rPr>
+              <a:t>σ</a:t>
+            </a:r>
+            <a:r>
+              <a:rPr sz="1150" b="0">
+                <a:solidFill>
+                  <a:srgbClr val="6B7787"/>
+                </a:solidFill>
+                <a:latin typeface="Avenir Next"/>
+              </a:rPr>
+              <a:t>  volatility</a:t>
             </a:r>
           </a:p>
         </p:txBody>

</xml_diff>